<commit_message>
Update .gitignore to exclude .venv-pptx and replace the existing PowerPoint file with a new version.
</commit_message>
<xml_diff>
--- a/PaolaCornejo_Examen_IE.pptx
+++ b/PaolaCornejo_Examen_IE.pptx
@@ -6784,6 +6784,10 @@
             <a:prstDash val="solid"/>
           </a:ln>
         </p:spPr>
+        <p:txBody>
+          <a:bodyPr/>
+          <a:p/>
+        </p:txBody>
       </p:sp>
       <p:sp>
         <p:nvSpPr>
@@ -6813,6 +6817,10 @@
             <a:prstDash val="solid"/>
           </a:ln>
         </p:spPr>
+        <p:txBody>
+          <a:bodyPr/>
+          <a:p/>
+        </p:txBody>
       </p:sp>
       <p:sp>
         <p:nvSpPr>
@@ -6842,6 +6850,10 @@
             <a:prstDash val="solid"/>
           </a:ln>
         </p:spPr>
+        <p:txBody>
+          <a:bodyPr/>
+          <a:p/>
+        </p:txBody>
       </p:sp>
       <p:sp>
         <p:nvSpPr>
@@ -6876,7 +6888,7 @@
                 <a:ea typeface="Arial" pitchFamily="34" charset="-122"/>
                 <a:cs typeface="Arial" pitchFamily="34" charset="-120"/>
               </a:rPr>
-              <a:t>IDEACIÓN · SCAMPER + IA</a:t>
+              <a:t>IDEACIÓN · SCAMPER + Enfoque Tradicional Optimizado</a:t>
             </a:r>
             <a:endParaRPr lang="en-US" sz="1100" dirty="0"/>
           </a:p>
@@ -6915,7 +6927,7 @@
                 <a:ea typeface="Arial" pitchFamily="34" charset="-122"/>
                 <a:cs typeface="Arial" pitchFamily="34" charset="-120"/>
               </a:rPr>
-              <a:t>3. La Solución — Microlearning inteligente</a:t>
+              <a:t>3. La Solución — Microlearning con casos reales</a:t>
             </a:r>
             <a:endParaRPr lang="en-US" sz="2600" dirty="0"/>
           </a:p>
@@ -6947,6 +6959,10 @@
             <a:prstDash val="solid"/>
           </a:ln>
         </p:spPr>
+        <p:txBody>
+          <a:bodyPr/>
+          <a:p/>
+        </p:txBody>
       </p:sp>
       <p:sp>
         <p:nvSpPr>
@@ -6981,7 +6997,7 @@
                 <a:ea typeface="Arial" pitchFamily="34" charset="-122"/>
                 <a:cs typeface="Arial" pitchFamily="34" charset="-120"/>
               </a:rPr>
-              <a:t>Idea núcleo: microcápsulas 3–5 min + IA + gamificación ligera + evaluación práctica inmediata.</a:t>
+              <a:t>Idea núcleo: Microcápsulas de 3–5 min + Casos multimedia de actores reales + Gamificación ligera + Evaluación práctica inmediata.</a:t>
             </a:r>
             <a:endParaRPr lang="en-US" sz="1400" dirty="0"/>
           </a:p>
@@ -7427,7 +7443,7 @@
                           <a:ea typeface="Arial" pitchFamily="34" charset="-122"/>
                           <a:cs typeface="Arial" pitchFamily="34" charset="-120"/>
                         </a:rPr>
-                        <a:t>Sustituir PDF/módulos largos por microcápsulas + avatar IA</a:t>
+                        <a:t>Sustituir manuales PDF y módulos largos por microcápsulas interactivas con videos de casos reales / dramatizaciones.</a:t>
                       </a:r>
                       <a:endParaRPr lang="en-US" sz="900" dirty="0">
                         <a:latin typeface="Arial" charset="0"/>
@@ -7474,7 +7490,7 @@
                           <a:ea typeface="Arial" pitchFamily="34" charset="-122"/>
                           <a:cs typeface="Arial" pitchFamily="34" charset="-120"/>
                         </a:rPr>
-                        <a:t>Combinar aprendizaje con flujo diario (intranet/correo)</a:t>
+                        <a:t>Combinar aprendizaje con flujo diario (intranet/correo) mediante píldoras formativas.</a:t>
                       </a:r>
                       <a:endParaRPr lang="en-US" sz="900" dirty="0">
                         <a:latin typeface="Arial" charset="0"/>
@@ -7521,7 +7537,7 @@
                           <a:ea typeface="Arial" pitchFamily="34" charset="-122"/>
                           <a:cs typeface="Arial" pitchFamily="34" charset="-120"/>
                         </a:rPr>
-                        <a:t>Adaptar gamificación ligera (progreso/insignias)</a:t>
+                        <a:t>Adaptar gamificación ligera (progreso/insignias) a cursos institucionales.</a:t>
                       </a:r>
                       <a:endParaRPr lang="en-US" sz="900" dirty="0">
                         <a:latin typeface="Arial" charset="0"/>
@@ -7568,7 +7584,7 @@
                           <a:ea typeface="Arial" pitchFamily="34" charset="-122"/>
                           <a:cs typeface="Arial" pitchFamily="34" charset="-120"/>
                         </a:rPr>
-                        <a:t>Modificar a rutas adaptativas según respuestas</a:t>
+                        <a:t>Modificar a rutas de decisión ramificadas según respuestas previas.</a:t>
                       </a:r>
                       <a:endParaRPr lang="en-US" sz="900" dirty="0">
                         <a:latin typeface="Arial" charset="0"/>
@@ -7615,7 +7631,7 @@
                           <a:ea typeface="Arial" pitchFamily="34" charset="-122"/>
                           <a:cs typeface="Arial" pitchFamily="34" charset="-120"/>
                         </a:rPr>
-                        <a:t>Otros usos: consulta just-in-time operativa</a:t>
+                        <a:t>Otros usos: consulta just-in-time de procedimientos operativos estandarizados.</a:t>
                       </a:r>
                       <a:endParaRPr lang="en-US" sz="900" dirty="0">
                         <a:latin typeface="Arial" charset="0"/>
@@ -7662,7 +7678,7 @@
                           <a:ea typeface="Arial" pitchFamily="34" charset="-122"/>
                           <a:cs typeface="Arial" pitchFamily="34" charset="-120"/>
                         </a:rPr>
-                        <a:t>Eliminar quizzes teóricos largos → práctica por cápsula</a:t>
+                        <a:t>Eliminar quizzes teóricos largos → práctica de resolución de casos por cápsula.</a:t>
                       </a:r>
                       <a:endParaRPr lang="en-US" sz="900" dirty="0">
                         <a:latin typeface="Arial" charset="0"/>
@@ -7709,7 +7725,7 @@
                           <a:ea typeface="Arial" pitchFamily="34" charset="-122"/>
                           <a:cs typeface="Arial" pitchFamily="34" charset="-120"/>
                         </a:rPr>
-                        <a:t>Reordenar: desafío práctico primero, teoría después</a:t>
+                        <a:t>Reordenar: desafío práctico primero, teoría después.</a:t>
                       </a:r>
                       <a:endParaRPr lang="en-US" sz="900" dirty="0">
                         <a:latin typeface="Arial" charset="0"/>
@@ -8082,7 +8098,7 @@
                           <a:ea typeface="Arial" pitchFamily="34" charset="-122"/>
                           <a:cs typeface="Arial" pitchFamily="34" charset="-120"/>
                         </a:rPr>
-                        <a:t>Microlearning + IA</a:t>
+                        <a:t>Microlearning + Casos Reales</a:t>
                       </a:r>
                       <a:endParaRPr lang="en-US" sz="1100" dirty="0">
                         <a:latin typeface="Arial" charset="0"/>
@@ -8223,7 +8239,7 @@
                           <a:ea typeface="Arial" pitchFamily="34" charset="-122"/>
                           <a:cs typeface="Arial" pitchFamily="34" charset="-120"/>
                         </a:rPr>
-                        <a:t>Avatares / generación asistida</a:t>
+                        <a:t>Videos / dramatizaciones de terreno</a:t>
                       </a:r>
                       <a:endParaRPr lang="en-US" sz="1100" dirty="0">
                         <a:latin typeface="Arial" charset="0"/>
@@ -8366,7 +8382,7 @@
                           <a:ea typeface="Arial" pitchFamily="34" charset="-122"/>
                           <a:cs typeface="Arial" pitchFamily="34" charset="-120"/>
                         </a:rPr>
-                        <a:t>Más motivación</a:t>
+                        <a:t>Más motivación y finalización</a:t>
                       </a:r>
                       <a:endParaRPr lang="en-US" sz="1100" dirty="0">
                         <a:latin typeface="Arial" charset="0"/>
@@ -8697,7 +8713,7 @@
                           <a:ea typeface="Arial" pitchFamily="34" charset="-122"/>
                           <a:cs typeface="Arial" pitchFamily="34" charset="-120"/>
                         </a:rPr>
-                        <a:t>Feedback contextual</a:t>
+                        <a:t>Feedback contextual y de pares</a:t>
                       </a:r>
                       <a:endParaRPr lang="en-US" sz="1100" dirty="0">
                         <a:latin typeface="Arial" charset="0"/>
@@ -8805,6 +8821,10 @@
             <a:prstDash val="solid"/>
           </a:ln>
         </p:spPr>
+        <p:txBody>
+          <a:bodyPr/>
+          <a:p/>
+        </p:txBody>
       </p:sp>
       <p:sp>
         <p:nvSpPr>
@@ -8839,7 +8859,7 @@
                 <a:ea typeface="Arial" pitchFamily="34" charset="-122"/>
                 <a:cs typeface="Arial" pitchFamily="34" charset="-120"/>
               </a:rPr>
-              <a:t>Trazabilidad IA (síntesis) · Gemini/ChatGPT</a:t>
+              <a:t>Enfoque tradicional optimizado</a:t>
             </a:r>
             <a:endParaRPr lang="en-US" sz="1200" dirty="0"/>
           </a:p>
@@ -8878,7 +8898,7 @@
                 <a:ea typeface="Arial" pitchFamily="34" charset="-122"/>
                 <a:cs typeface="Arial" pitchFamily="34" charset="-120"/>
               </a:rPr>
-              <a:t>Hallazgo: priorizar microlearning vs gamificación compleja. Decisión humana: micro + gamificación ligera. Riesgo IA: asumir plataforma propia → ajuste: integrar vía LMS/SCORM. 2ª interacción: barreras (tiempo, fatiga, irrelevancia) → cápsula ≤5 min + tiempo visible antes de empezar.</a:t>
+              <a:t>Priorizar microcápsulas con videos de casos reales / dramatizaciones y simulaciones ramificadas estáticas. Integración vía LMS/SCORM. Cápsula ≤5 min + tiempo visible antes de empezar. Sin plataforma propia ni avatares de IA.</a:t>
             </a:r>
             <a:endParaRPr lang="en-US" sz="1200" dirty="0"/>
           </a:p>
@@ -8972,6 +8992,10 @@
             <a:prstDash val="solid"/>
           </a:ln>
         </p:spPr>
+        <p:txBody>
+          <a:bodyPr/>
+          <a:p/>
+        </p:txBody>
       </p:sp>
       <p:sp>
         <p:nvSpPr>
@@ -9001,6 +9025,10 @@
             <a:prstDash val="solid"/>
           </a:ln>
         </p:spPr>
+        <p:txBody>
+          <a:bodyPr/>
+          <a:p/>
+        </p:txBody>
       </p:sp>
       <p:sp>
         <p:nvSpPr>
@@ -9030,6 +9058,10 @@
             <a:prstDash val="solid"/>
           </a:ln>
         </p:spPr>
+        <p:txBody>
+          <a:bodyPr/>
+          <a:p/>
+        </p:txBody>
       </p:sp>
       <p:sp>
         <p:nvSpPr>
@@ -9159,6 +9191,10 @@
             <a:prstDash val="solid"/>
           </a:ln>
         </p:spPr>
+        <p:txBody>
+          <a:bodyPr/>
+          <a:p/>
+        </p:txBody>
       </p:sp>
       <p:sp>
         <p:nvSpPr>
@@ -9271,7 +9307,7 @@
                 <a:ea typeface="Arial" pitchFamily="34" charset="-122"/>
                 <a:cs typeface="Arial" pitchFamily="34" charset="-120"/>
               </a:rPr>
-              <a:t>• 2 Aprendizaje — avatar + Solo audio</a:t>
+              <a:t>• 2 Aprendizaje — Video de caso real / dramatización + Solo audio</a:t>
             </a:r>
             <a:endParaRPr lang="en-US" sz="1200" dirty="0"/>
           </a:p>
@@ -9310,7 +9346,7 @@
                 <a:ea typeface="Arial" pitchFamily="34" charset="-122"/>
                 <a:cs typeface="Arial" pitchFamily="34" charset="-120"/>
               </a:rPr>
-              <a:t>• 3 Evaluación — botones táctiles</a:t>
+              <a:t>• 3 Evaluación — dilemas y decisiones (botones táctiles)</a:t>
             </a:r>
             <a:endParaRPr lang="en-US" sz="1200" dirty="0"/>
           </a:p>
@@ -9349,7 +9385,7 @@
                 <a:ea typeface="Arial" pitchFamily="34" charset="-122"/>
                 <a:cs typeface="Arial" pitchFamily="34" charset="-120"/>
               </a:rPr>
-              <a:t>• 4 Resultado — 100% + insignia</a:t>
+              <a:t>• 4 Resultado — 100% de avance + insignia obtenida</a:t>
             </a:r>
             <a:endParaRPr lang="en-US" sz="1200" dirty="0"/>
           </a:p>
@@ -9388,7 +9424,7 @@
                 <a:ea typeface="Arial" pitchFamily="34" charset="-122"/>
                 <a:cs typeface="Arial" pitchFamily="34" charset="-120"/>
               </a:rPr>
-              <a:t>• 5 Dashboard institucional</a:t>
+              <a:t>• 5 Dashboard institucional — métricas en tiempo real</a:t>
             </a:r>
             <a:endParaRPr lang="en-US" sz="1200" dirty="0"/>
           </a:p>
@@ -9427,7 +9463,7 @@
                 <a:ea typeface="Arial" pitchFamily="34" charset="-122"/>
                 <a:cs typeface="Arial" pitchFamily="34" charset="-120"/>
               </a:rPr>
-              <a:t>Ajuste vs testeo previo</a:t>
+              <a:t>Trazabilidad dolor → solución</a:t>
             </a:r>
             <a:endParaRPr lang="en-US" sz="1200" dirty="0"/>
           </a:p>
@@ -9466,7 +9502,7 @@
                 <a:ea typeface="Arial" pitchFamily="34" charset="-122"/>
                 <a:cs typeface="Arial" pitchFamily="34" charset="-120"/>
               </a:rPr>
-              <a:t>Se eliminó drag-and-drop; botones grandes + modo Solo audio + “Intentos ilimitados”.</a:t>
+              <a:t>Falta de tiempo → cápsula 3–5 min · Desmotivación → progreso + insignia · Baja retención → evaluación práctica por casos · Falta de seguimiento → dashboard institucional.</a:t>
             </a:r>
             <a:endParaRPr lang="en-US" sz="1200" dirty="0"/>
           </a:p>
@@ -9518,7 +9554,7 @@
                           <a:ea typeface="Arial" pitchFamily="34" charset="-122"/>
                           <a:cs typeface="Arial" pitchFamily="34" charset="-120"/>
                         </a:rPr>
-                        <a:t>Problema</a:t>
+                        <a:t>Dolor</a:t>
                       </a:r>
                       <a:endParaRPr lang="en-US" sz="1200" dirty="0">
                         <a:latin typeface="Arial" charset="0"/>
@@ -9568,7 +9604,7 @@
                           <a:ea typeface="Arial" pitchFamily="34" charset="-122"/>
                           <a:cs typeface="Arial" pitchFamily="34" charset="-120"/>
                         </a:rPr>
-                        <a:t>Insight usuario</a:t>
+                        <a:t>Insight</a:t>
                       </a:r>
                       <a:endParaRPr lang="en-US" sz="1200" dirty="0">
                         <a:latin typeface="Arial" charset="0"/>
@@ -9618,7 +9654,7 @@
                           <a:ea typeface="Arial" pitchFamily="34" charset="-122"/>
                           <a:cs typeface="Arial" pitchFamily="34" charset="-120"/>
                         </a:rPr>
-                        <a:t>Funcionalidad</a:t>
+                        <a:t>Solución SmartCaps</a:t>
                       </a:r>
                       <a:endParaRPr lang="en-US" sz="1200" dirty="0">
                         <a:latin typeface="Arial" charset="0"/>
@@ -9814,7 +9850,7 @@
                           <a:ea typeface="Arial" pitchFamily="34" charset="-122"/>
                           <a:cs typeface="Arial" pitchFamily="34" charset="-120"/>
                         </a:rPr>
-                        <a:t>Cápsula 3–5 min + tiempo visible</a:t>
+                        <a:t>Cápsula de 3–5 min + tiempo visible</a:t>
                       </a:r>
                       <a:endParaRPr lang="en-US" sz="1000" dirty="0">
                         <a:latin typeface="Arial" charset="0"/>
@@ -9861,7 +9897,7 @@
                           <a:ea typeface="Arial" pitchFamily="34" charset="-122"/>
                           <a:cs typeface="Arial" pitchFamily="34" charset="-120"/>
                         </a:rPr>
-                        <a:t>Evidencia testeo: brevedad gatilla interés</a:t>
+                        <a:t>Brevedad gatilla interés</a:t>
                       </a:r>
                       <a:endParaRPr lang="en-US" sz="1000" dirty="0">
                         <a:latin typeface="Arial" charset="0"/>
@@ -9910,7 +9946,7 @@
                           <a:ea typeface="Arial" pitchFamily="34" charset="-122"/>
                           <a:cs typeface="Arial" pitchFamily="34" charset="-120"/>
                         </a:rPr>
-                        <a:t>Baja retención / sin feedback</a:t>
+                        <a:t>Baja retención / desmotivación</a:t>
                       </a:r>
                       <a:endParaRPr lang="en-US" sz="1000" dirty="0">
                         <a:latin typeface="Arial" charset="0"/>
@@ -9957,7 +9993,7 @@
                           <a:ea typeface="Arial" pitchFamily="34" charset="-122"/>
                           <a:cs typeface="Arial" pitchFamily="34" charset="-120"/>
                         </a:rPr>
-                        <a:t>Olvida si es pasivo; necesita metas cortas</a:t>
+                        <a:t>Olvida si es pasivo; necesita metas cortas y casos reales</a:t>
                       </a:r>
                       <a:endParaRPr lang="en-US" sz="1000" dirty="0">
                         <a:latin typeface="Arial" charset="0"/>
@@ -10004,7 +10040,7 @@
                           <a:ea typeface="Arial" pitchFamily="34" charset="-122"/>
                           <a:cs typeface="Arial" pitchFamily="34" charset="-120"/>
                         </a:rPr>
-                        <a:t>Quiz práctico + insignia + dashboard</a:t>
+                        <a:t>Evaluación práctica por casos + progreso/insignia + dashboard</a:t>
                       </a:r>
                       <a:endParaRPr lang="en-US" sz="1000" dirty="0">
                         <a:latin typeface="Arial" charset="0"/>
@@ -10051,7 +10087,7 @@
                           <a:ea typeface="Arial" pitchFamily="34" charset="-122"/>
                           <a:cs typeface="Arial" pitchFamily="34" charset="-120"/>
                         </a:rPr>
-                        <a:t>Evidencia práctica activa / supuesto refuerzo visual</a:t>
+                        <a:t>Práctica activa y refuerzo visual</a:t>
                       </a:r>
                       <a:endParaRPr lang="en-US" sz="1000" dirty="0">
                         <a:latin typeface="Arial" charset="0"/>
@@ -10135,6 +10171,10 @@
             <a:prstDash val="solid"/>
           </a:ln>
         </p:spPr>
+        <p:txBody>
+          <a:bodyPr/>
+          <a:p/>
+        </p:txBody>
       </p:sp>
       <p:sp>
         <p:nvSpPr>
@@ -10164,6 +10204,10 @@
             <a:prstDash val="solid"/>
           </a:ln>
         </p:spPr>
+        <p:txBody>
+          <a:bodyPr/>
+          <a:p/>
+        </p:txBody>
       </p:sp>
       <p:sp>
         <p:nvSpPr>
@@ -10193,6 +10237,10 @@
             <a:prstDash val="solid"/>
           </a:ln>
         </p:spPr>
+        <p:txBody>
+          <a:bodyPr/>
+          <a:p/>
+        </p:txBody>
       </p:sp>
       <p:sp>
         <p:nvSpPr>
@@ -10298,6 +10346,10 @@
             <a:prstDash val="solid"/>
           </a:ln>
         </p:spPr>
+        <p:txBody>
+          <a:bodyPr/>
+          <a:p/>
+        </p:txBody>
       </p:sp>
       <p:sp>
         <p:nvSpPr>
@@ -10403,6 +10455,10 @@
             <a:prstDash val="solid"/>
           </a:ln>
         </p:spPr>
+        <p:txBody>
+          <a:bodyPr/>
+          <a:p/>
+        </p:txBody>
       </p:sp>
       <p:sp>
         <p:nvSpPr>
@@ -10508,6 +10564,10 @@
             <a:prstDash val="solid"/>
           </a:ln>
         </p:spPr>
+        <p:txBody>
+          <a:bodyPr/>
+          <a:p/>
+        </p:txBody>
       </p:sp>
       <p:sp>
         <p:nvSpPr>
@@ -10581,7 +10641,7 @@
                 <a:ea typeface="Arial" pitchFamily="34" charset="-122"/>
                 <a:cs typeface="Arial" pitchFamily="34" charset="-120"/>
               </a:rPr>
-              <a:t>Diseño instruccional, IA, multimedia, LMS/SCORM</a:t>
+              <a:t>Diseño instruccional experto, producción audiovisual, multimedia y LMS/SCORM</a:t>
             </a:r>
             <a:endParaRPr lang="en-US" sz="1100" dirty="0"/>
           </a:p>
@@ -10613,6 +10673,10 @@
             <a:prstDash val="solid"/>
           </a:ln>
         </p:spPr>
+        <p:txBody>
+          <a:bodyPr/>
+          <a:p/>
+        </p:txBody>
       </p:sp>
       <p:sp>
         <p:nvSpPr>
@@ -10686,7 +10750,7 @@
                 <a:ea typeface="Arial" pitchFamily="34" charset="-122"/>
                 <a:cs typeface="Arial" pitchFamily="34" charset="-120"/>
               </a:rPr>
-              <a:t>Capacitación breve, atractiva, medible y adaptable (microlearning + IA)</a:t>
+              <a:t>Capacitación breve, atractiva, medible y adaptable (microlearning con casos multimedia y simulaciones ramificadas)</a:t>
             </a:r>
             <a:endParaRPr lang="en-US" sz="1100" dirty="0"/>
           </a:p>
@@ -10718,6 +10782,10 @@
             <a:prstDash val="solid"/>
           </a:ln>
         </p:spPr>
+        <p:txBody>
+          <a:bodyPr/>
+          <a:p/>
+        </p:txBody>
       </p:sp>
       <p:sp>
         <p:nvSpPr>
@@ -10823,6 +10891,10 @@
             <a:prstDash val="solid"/>
           </a:ln>
         </p:spPr>
+        <p:txBody>
+          <a:bodyPr/>
+          <a:p/>
+        </p:txBody>
       </p:sp>
       <p:sp>
         <p:nvSpPr>
@@ -10928,6 +11000,10 @@
             <a:prstDash val="solid"/>
           </a:ln>
         </p:spPr>
+        <p:txBody>
+          <a:bodyPr/>
+          <a:p/>
+        </p:txBody>
       </p:sp>
       <p:sp>
         <p:nvSpPr>
@@ -11033,6 +11109,10 @@
             <a:prstDash val="solid"/>
           </a:ln>
         </p:spPr>
+        <p:txBody>
+          <a:bodyPr/>
+          <a:p/>
+        </p:txBody>
       </p:sp>
       <p:sp>
         <p:nvSpPr>
@@ -11106,7 +11186,7 @@
                 <a:ea typeface="Arial" pitchFamily="34" charset="-122"/>
                 <a:cs typeface="Arial" pitchFamily="34" charset="-120"/>
               </a:rPr>
-              <a:t>Personal, IA, producción AV, software, infraestructura y soporte</a:t>
+              <a:t>Personal académico, producción audiovisual (actores/videos), software, infraestructura y soporte</a:t>
             </a:r>
             <a:endParaRPr lang="en-US" sz="1100" dirty="0"/>
           </a:p>
@@ -11138,6 +11218,10 @@
             <a:prstDash val="solid"/>
           </a:ln>
         </p:spPr>
+        <p:txBody>
+          <a:bodyPr/>
+          <a:p/>
+        </p:txBody>
       </p:sp>
       <p:sp>
         <p:nvSpPr>
@@ -11243,6 +11327,10 @@
             <a:prstDash val="solid"/>
           </a:ln>
         </p:spPr>
+        <p:txBody>
+          <a:bodyPr/>
+          <a:p/>
+        </p:txBody>
       </p:sp>
       <p:sp>
         <p:nvSpPr>
@@ -11316,7 +11404,7 @@
                 <a:ea typeface="Arial" pitchFamily="34" charset="-122"/>
                 <a:cs typeface="Arial" pitchFamily="34" charset="-120"/>
               </a:rPr>
-              <a:t>Cliente institucional → dolor del aprendiz (tiempo / motivación / retención) → SmartCaps (micro + IA + evaluación + métricas)</a:t>
+              <a:t>Cliente institucional → dolor del aprendiz (tiempo / motivación / retención) → SmartCaps (micro + casos reales + evaluación + métricas)</a:t>
             </a:r>
             <a:endParaRPr lang="en-US" sz="1400" dirty="0"/>
           </a:p>
@@ -11348,6 +11436,10 @@
             <a:prstDash val="solid"/>
           </a:ln>
         </p:spPr>
+        <p:txBody>
+          <a:bodyPr/>
+          <a:p/>
+        </p:txBody>
       </p:sp>
       <p:sp>
         <p:nvSpPr>
@@ -11437,6 +11529,10 @@
             <a:prstDash val="solid"/>
           </a:ln>
         </p:spPr>
+        <p:txBody>
+          <a:bodyPr/>
+          <a:p/>
+        </p:txBody>
       </p:sp>
       <p:sp>
         <p:nvSpPr>
@@ -11466,6 +11562,10 @@
             <a:prstDash val="solid"/>
           </a:ln>
         </p:spPr>
+        <p:txBody>
+          <a:bodyPr/>
+          <a:p/>
+        </p:txBody>
       </p:sp>
       <p:sp>
         <p:nvSpPr>
@@ -11495,6 +11595,10 @@
             <a:prstDash val="solid"/>
           </a:ln>
         </p:spPr>
+        <p:txBody>
+          <a:bodyPr/>
+          <a:p/>
+        </p:txBody>
       </p:sp>
       <p:sp>
         <p:nvSpPr>
@@ -11600,6 +11704,10 @@
             <a:prstDash val="solid"/>
           </a:ln>
         </p:spPr>
+        <p:txBody>
+          <a:bodyPr/>
+          <a:p/>
+        </p:txBody>
       </p:sp>
       <p:sp>
         <p:nvSpPr>
@@ -11822,6 +11930,10 @@
             <a:prstDash val="solid"/>
           </a:ln>
         </p:spPr>
+        <p:txBody>
+          <a:bodyPr/>
+          <a:p/>
+        </p:txBody>
       </p:sp>
       <p:sp>
         <p:nvSpPr>
@@ -11973,7 +12085,7 @@
                 <a:ea typeface="Arial" pitchFamily="34" charset="-122"/>
                 <a:cs typeface="Arial" pitchFamily="34" charset="-120"/>
               </a:rPr>
-              <a:t>🤖  IA + interacción</a:t>
+              <a:t>🎬  Casos reales + interacción multimedia</a:t>
             </a:r>
             <a:endParaRPr lang="en-US" sz="1500" dirty="0"/>
           </a:p>
@@ -12122,6 +12234,10 @@
             <a:prstDash val="solid"/>
           </a:ln>
         </p:spPr>
+        <p:txBody>
+          <a:bodyPr/>
+          <a:p/>
+        </p:txBody>
       </p:sp>
       <p:sp>
         <p:nvSpPr>
@@ -12211,6 +12327,10 @@
             <a:prstDash val="solid"/>
           </a:ln>
         </p:spPr>
+        <p:txBody>
+          <a:bodyPr/>
+          <a:p/>
+        </p:txBody>
       </p:sp>
       <p:sp>
         <p:nvSpPr>
@@ -12240,6 +12360,10 @@
             <a:prstDash val="solid"/>
           </a:ln>
         </p:spPr>
+        <p:txBody>
+          <a:bodyPr/>
+          <a:p/>
+        </p:txBody>
       </p:sp>
       <p:sp>
         <p:nvSpPr>
@@ -12269,6 +12393,10 @@
             <a:prstDash val="solid"/>
           </a:ln>
         </p:spPr>
+        <p:txBody>
+          <a:bodyPr/>
+          <a:p/>
+        </p:txBody>
       </p:sp>
       <p:sp>
         <p:nvSpPr>
@@ -12374,6 +12502,10 @@
             <a:prstDash val="solid"/>
           </a:ln>
         </p:spPr>
+        <p:txBody>
+          <a:bodyPr/>
+          <a:p/>
+        </p:txBody>
       </p:sp>
       <p:sp>
         <p:nvSpPr>
@@ -12401,6 +12533,10 @@
             <a:prstDash val="solid"/>
           </a:ln>
         </p:spPr>
+        <p:txBody>
+          <a:bodyPr/>
+          <a:p/>
+        </p:txBody>
       </p:sp>
       <p:sp>
         <p:nvSpPr>
@@ -12513,7 +12649,7 @@
                 <a:ea typeface="Arial" pitchFamily="34" charset="-122"/>
                 <a:cs typeface="Arial" pitchFamily="34" charset="-120"/>
               </a:rPr>
-              <a:t>¿Cuánto conocimiento se pierde cuando una capacitación se completa solo porque es obligatoria?</a:t>
+              <a:t>¿Cuánto conocimiento se pierde cuando una capacitación corporativa u online se completa solo porque es obligatoria?</a:t>
             </a:r>
             <a:endParaRPr lang="en-US" sz="1300" dirty="0"/>
           </a:p>
@@ -12545,6 +12681,10 @@
             <a:prstDash val="solid"/>
           </a:ln>
         </p:spPr>
+        <p:txBody>
+          <a:bodyPr/>
+          <a:p/>
+        </p:txBody>
       </p:sp>
       <p:sp>
         <p:nvSpPr>
@@ -12572,6 +12712,10 @@
             <a:prstDash val="solid"/>
           </a:ln>
         </p:spPr>
+        <p:txBody>
+          <a:bodyPr/>
+          <a:p/>
+        </p:txBody>
       </p:sp>
       <p:sp>
         <p:nvSpPr>
@@ -12684,7 +12828,7 @@
                 <a:ea typeface="Arial" pitchFamily="34" charset="-122"/>
                 <a:cs typeface="Arial" pitchFamily="34" charset="-120"/>
               </a:rPr>
-              <a:t>SmartCaps transforma contenidos extensos en microcápsulas interactivas de 3–5 minutos.</a:t>
+              <a:t>SmartCaps transforma contenidos extensos en microcápsulas interactivas de 3–5 minutos basadas en escenarios y casos reales.</a:t>
             </a:r>
             <a:endParaRPr lang="en-US" sz="1300" dirty="0"/>
           </a:p>
@@ -12716,6 +12860,10 @@
             <a:prstDash val="solid"/>
           </a:ln>
         </p:spPr>
+        <p:txBody>
+          <a:bodyPr/>
+          <a:p/>
+        </p:txBody>
       </p:sp>
       <p:sp>
         <p:nvSpPr>
@@ -12743,6 +12891,10 @@
             <a:prstDash val="solid"/>
           </a:ln>
         </p:spPr>
+        <p:txBody>
+          <a:bodyPr/>
+          <a:p/>
+        </p:txBody>
       </p:sp>
       <p:sp>
         <p:nvSpPr>
@@ -12855,7 +13007,7 @@
                 <a:ea typeface="Arial" pitchFamily="34" charset="-122"/>
                 <a:cs typeface="Arial" pitchFamily="34" charset="-120"/>
               </a:rPr>
-              <a:t>IA + evaluación práctica + gamificación ligera: aprender sin detener la jornada y dar trazabilidad a la institución (LMS/SCORM).</a:t>
+              <a:t>Casos multimedia dinámicos + evaluación práctica + gamificación ligera: aprender sin detener la jornada y dar trazabilidad completa a la institución (vía LMS/SCORM).</a:t>
             </a:r>
             <a:endParaRPr lang="en-US" sz="1300" dirty="0"/>
           </a:p>
@@ -12887,6 +13039,10 @@
             <a:prstDash val="solid"/>
           </a:ln>
         </p:spPr>
+        <p:txBody>
+          <a:bodyPr/>
+          <a:p/>
+        </p:txBody>
       </p:sp>
       <p:sp>
         <p:nvSpPr>
@@ -12914,6 +13070,10 @@
             <a:prstDash val="solid"/>
           </a:ln>
         </p:spPr>
+        <p:txBody>
+          <a:bodyPr/>
+          <a:p/>
+        </p:txBody>
       </p:sp>
       <p:sp>
         <p:nvSpPr>
@@ -14149,6 +14309,10 @@
             <a:prstDash val="solid"/>
           </a:ln>
         </p:spPr>
+        <p:txBody>
+          <a:bodyPr/>
+          <a:p/>
+        </p:txBody>
       </p:sp>
       <p:sp>
         <p:nvSpPr>
@@ -14178,6 +14342,10 @@
             <a:prstDash val="solid"/>
           </a:ln>
         </p:spPr>
+        <p:txBody>
+          <a:bodyPr/>
+          <a:p/>
+        </p:txBody>
       </p:sp>
       <p:sp>
         <p:nvSpPr>
@@ -14207,6 +14375,10 @@
             <a:prstDash val="solid"/>
           </a:ln>
         </p:spPr>
+        <p:txBody>
+          <a:bodyPr/>
+          <a:p/>
+        </p:txBody>
       </p:sp>
       <p:sp>
         <p:nvSpPr>
@@ -14241,7 +14413,7 @@
                 <a:ea typeface="Arial" pitchFamily="34" charset="-122"/>
                 <a:cs typeface="Arial" pitchFamily="34" charset="-120"/>
               </a:rPr>
-              <a:t>ANEXO · PLANTILLA 5 CAMPOS</a:t>
+              <a:t>ANEXO · CRITERIOS DE DISEÑO</a:t>
             </a:r>
             <a:endParaRPr lang="en-US" sz="1100" dirty="0"/>
           </a:p>
@@ -14280,7 +14452,7 @@
                 <a:ea typeface="Arial" pitchFamily="34" charset="-122"/>
                 <a:cs typeface="Arial" pitchFamily="34" charset="-120"/>
               </a:rPr>
-              <a:t>9. Trazabilidad IA (2 interacciones)</a:t>
+              <a:t>9. Criterios de diseño y validación pedagógica</a:t>
             </a:r>
             <a:endParaRPr lang="en-US" sz="2600" dirty="0"/>
           </a:p>
@@ -14312,6 +14484,10 @@
             <a:prstDash val="solid"/>
           </a:ln>
         </p:spPr>
+        <p:txBody>
+          <a:bodyPr/>
+          <a:p/>
+        </p:txBody>
       </p:sp>
       <p:sp>
         <p:nvSpPr>
@@ -14346,7 +14522,7 @@
                 <a:ea typeface="Arial" pitchFamily="34" charset="-122"/>
                 <a:cs typeface="Arial" pitchFamily="34" charset="-120"/>
               </a:rPr>
-              <a:t>Interacción 1 — Gemini</a:t>
+              <a:t>Criterio 1 — Formato de contenido</a:t>
             </a:r>
             <a:endParaRPr lang="en-US" sz="1400" dirty="0"/>
           </a:p>
@@ -14385,7 +14561,7 @@
                 <a:ea typeface="Arial" pitchFamily="34" charset="-122"/>
                 <a:cs typeface="Arial" pitchFamily="34" charset="-120"/>
               </a:rPr>
-              <a:t>1. Objetivo: </a:t>
+              <a:t>Priorizar la inmersión mediante dramatizaciones en video de situaciones reales de terreno frente a la teoría estática, validando que el formato de 3 a 5 minutos disminuye la fatiga digital.</a:t>
             </a:r>
             <a:pPr indent="0" marL="0">
               <a:buNone/>
@@ -14399,8 +14575,7 @@
                 <a:ea typeface="Arial" pitchFamily="34" charset="-122"/>
                 <a:cs typeface="Arial" pitchFamily="34" charset="-120"/>
               </a:rPr>
-              <a:t>Comparar microlearning+IA vs gamificación robusta.
-</a:t>
+              <a:t/>
             </a:r>
             <a:pPr indent="0" marL="0">
               <a:buNone/>
@@ -14414,7 +14589,7 @@
                 <a:ea typeface="Arial" pitchFamily="34" charset="-122"/>
                 <a:cs typeface="Arial" pitchFamily="34" charset="-120"/>
               </a:rPr>
-              <a:t>2. Prompt: </a:t>
+              <a:t/>
             </a:r>
             <a:pPr indent="0" marL="0">
               <a:buNone/>
@@ -14428,8 +14603,7 @@
                 <a:ea typeface="Arial" pitchFamily="34" charset="-122"/>
                 <a:cs typeface="Arial" pitchFamily="34" charset="-120"/>
               </a:rPr>
-              <a:t>viabilidad, costos e impacto en retención.
-</a:t>
+              <a:t/>
             </a:r>
             <a:pPr indent="0" marL="0">
               <a:buNone/>
@@ -14443,7 +14617,7 @@
                 <a:ea typeface="Arial" pitchFamily="34" charset="-122"/>
                 <a:cs typeface="Arial" pitchFamily="34" charset="-120"/>
               </a:rPr>
-              <a:t>3. Salida: </a:t>
+              <a:t/>
             </a:r>
             <a:pPr indent="0" marL="0">
               <a:buNone/>
@@ -14457,8 +14631,7 @@
                 <a:ea typeface="Arial" pitchFamily="34" charset="-122"/>
                 <a:cs typeface="Arial" pitchFamily="34" charset="-120"/>
               </a:rPr>
-              <a:t>microlearning más rápido/económico a corto plazo; gamificación profunda más costosa.
-</a:t>
+              <a:t/>
             </a:r>
             <a:pPr indent="0" marL="0">
               <a:buNone/>
@@ -14472,7 +14645,7 @@
                 <a:ea typeface="Arial" pitchFamily="34" charset="-122"/>
                 <a:cs typeface="Arial" pitchFamily="34" charset="-120"/>
               </a:rPr>
-              <a:t>4. Decisión: </a:t>
+              <a:t/>
             </a:r>
             <a:pPr indent="0" marL="0">
               <a:buNone/>
@@ -14486,8 +14659,7 @@
                 <a:ea typeface="Arial" pitchFamily="34" charset="-122"/>
                 <a:cs typeface="Arial" pitchFamily="34" charset="-120"/>
               </a:rPr>
-              <a:t>núcleo = microlearning + gamificación ligera.
-</a:t>
+              <a:t/>
             </a:r>
             <a:pPr indent="0" marL="0">
               <a:buNone/>
@@ -14501,7 +14673,7 @@
                 <a:ea typeface="Arial" pitchFamily="34" charset="-122"/>
                 <a:cs typeface="Arial" pitchFamily="34" charset="-120"/>
               </a:rPr>
-              <a:t>5. Riesgo: </a:t>
+              <a:t/>
             </a:r>
             <a:pPr indent="0" marL="0">
               <a:buNone/>
@@ -14515,7 +14687,7 @@
                 <a:ea typeface="Arial" pitchFamily="34" charset="-122"/>
                 <a:cs typeface="Arial" pitchFamily="34" charset="-120"/>
               </a:rPr>
-              <a:t>IA asumió plataforma propia → ajuste LMS/SCORM.</a:t>
+              <a:t/>
             </a:r>
             <a:endParaRPr lang="en-US" sz="1200" dirty="0"/>
           </a:p>
@@ -14547,6 +14719,10 @@
             <a:prstDash val="solid"/>
           </a:ln>
         </p:spPr>
+        <p:txBody>
+          <a:bodyPr/>
+          <a:p/>
+        </p:txBody>
       </p:sp>
       <p:sp>
         <p:nvSpPr>
@@ -14581,7 +14757,7 @@
                 <a:ea typeface="Arial" pitchFamily="34" charset="-122"/>
                 <a:cs typeface="Arial" pitchFamily="34" charset="-120"/>
               </a:rPr>
-              <a:t>Interacción 2 — Gemini</a:t>
+              <a:t>Criterio 2 — Accesibilidad y compatibilidad</a:t>
             </a:r>
             <a:endParaRPr lang="en-US" sz="1400" dirty="0"/>
           </a:p>
@@ -14620,7 +14796,7 @@
                 <a:ea typeface="Arial" pitchFamily="34" charset="-122"/>
                 <a:cs typeface="Arial" pitchFamily="34" charset="-120"/>
               </a:rPr>
-              <a:t>1. Objetivo: </a:t>
+              <a:t>Asegurar que los componentes interactivos funcionen de forma nativa en plataformas LMS existentes (como Moodle o SAP) mediante paquetes SCORM estándar, sin requerir desarrollos tecnológicos complejos ni plataformas externas.</a:t>
             </a:r>
             <a:pPr indent="0" marL="0">
               <a:buNone/>
@@ -14634,8 +14810,7 @@
                 <a:ea typeface="Arial" pitchFamily="34" charset="-122"/>
                 <a:cs typeface="Arial" pitchFamily="34" charset="-120"/>
               </a:rPr>
-              <a:t>Barreras de adopción en colaboradores.
-</a:t>
+              <a:t/>
             </a:r>
             <a:pPr indent="0" marL="0">
               <a:buNone/>
@@ -14649,7 +14824,7 @@
                 <a:ea typeface="Arial" pitchFamily="34" charset="-122"/>
                 <a:cs typeface="Arial" pitchFamily="34" charset="-120"/>
               </a:rPr>
-              <a:t>2. Prompt: </a:t>
+              <a:t/>
             </a:r>
             <a:pPr indent="0" marL="0">
               <a:buNone/>
@@ -14663,8 +14838,7 @@
                 <a:ea typeface="Arial" pitchFamily="34" charset="-122"/>
                 <a:cs typeface="Arial" pitchFamily="34" charset="-120"/>
               </a:rPr>
-              <a:t>3 barreras + mitigaciones de experiencia.
-</a:t>
+              <a:t/>
             </a:r>
             <a:pPr indent="0" marL="0">
               <a:buNone/>
@@ -14678,7 +14852,7 @@
                 <a:ea typeface="Arial" pitchFamily="34" charset="-122"/>
                 <a:cs typeface="Arial" pitchFamily="34" charset="-120"/>
               </a:rPr>
-              <a:t>3. Salida: </a:t>
+              <a:t/>
             </a:r>
             <a:pPr indent="0" marL="0">
               <a:buNone/>
@@ -14692,8 +14866,7 @@
                 <a:ea typeface="Arial" pitchFamily="34" charset="-122"/>
                 <a:cs typeface="Arial" pitchFamily="34" charset="-120"/>
               </a:rPr>
-              <a:t>falta de tiempo, fatiga digital, irrelevancia percibida.
-</a:t>
+              <a:t/>
             </a:r>
             <a:pPr indent="0" marL="0">
               <a:buNone/>
@@ -14707,7 +14880,7 @@
                 <a:ea typeface="Arial" pitchFamily="34" charset="-122"/>
                 <a:cs typeface="Arial" pitchFamily="34" charset="-120"/>
               </a:rPr>
-              <a:t>4. Decisión: </a:t>
+              <a:t/>
             </a:r>
             <a:pPr indent="0" marL="0">
               <a:buNone/>
@@ -14721,8 +14894,7 @@
                 <a:ea typeface="Arial" pitchFamily="34" charset="-122"/>
                 <a:cs typeface="Arial" pitchFamily="34" charset="-120"/>
               </a:rPr>
-              <a:t>≤5 min + contenido desde un “dolor” operativo.
-</a:t>
+              <a:t/>
             </a:r>
             <a:pPr indent="0" marL="0">
               <a:buNone/>
@@ -14736,7 +14908,7 @@
                 <a:ea typeface="Arial" pitchFamily="34" charset="-122"/>
                 <a:cs typeface="Arial" pitchFamily="34" charset="-120"/>
               </a:rPr>
-              <a:t>5. Riesgo: </a:t>
+              <a:t/>
             </a:r>
             <a:pPr indent="0" marL="0">
               <a:buNone/>
@@ -14750,7 +14922,7 @@
                 <a:ea typeface="Arial" pitchFamily="34" charset="-122"/>
                 <a:cs typeface="Arial" pitchFamily="34" charset="-120"/>
               </a:rPr>
-              <a:t>mitigaciones teóricas → funcionalidad concreta: mostrar minutos antes de iniciar.</a:t>
+              <a:t/>
             </a:r>
             <a:endParaRPr lang="en-US" sz="1200" dirty="0"/>
           </a:p>

</xml_diff>

<commit_message>
Update video script and README for SmartCaps prototype. Adjusted video duration requirements, clarified content focus, and emphasized the absence of AI and avatars. Enhanced descriptions for target audiences and improved user instructions in the LearningPlayer component. Updated UI elements for consistency and clarity.
</commit_message>
<xml_diff>
--- a/PaolaCornejo_Examen_IE.pptx
+++ b/PaolaCornejo_Examen_IE.pptx
@@ -1871,6 +1871,10 @@
             <a:prstDash val="solid"/>
           </a:ln>
         </p:spPr>
+        <p:txBody>
+          <a:bodyPr/>
+          <a:p/>
+        </p:txBody>
       </p:sp>
       <p:sp>
         <p:nvSpPr>
@@ -1900,6 +1904,10 @@
             <a:prstDash val="solid"/>
           </a:ln>
         </p:spPr>
+        <p:txBody>
+          <a:bodyPr/>
+          <a:p/>
+        </p:txBody>
       </p:sp>
       <p:sp>
         <p:nvSpPr>
@@ -1929,6 +1937,10 @@
             <a:prstDash val="solid"/>
           </a:ln>
         </p:spPr>
+        <p:txBody>
+          <a:bodyPr/>
+          <a:p/>
+        </p:txBody>
       </p:sp>
       <p:sp>
         <p:nvSpPr>
@@ -2034,6 +2046,10 @@
             <a:prstDash val="solid"/>
           </a:ln>
         </p:spPr>
+        <p:txBody>
+          <a:bodyPr/>
+          <a:p/>
+        </p:txBody>
       </p:sp>
       <p:sp>
         <p:nvSpPr>
@@ -2139,6 +2155,10 @@
             <a:prstDash val="solid"/>
           </a:ln>
         </p:spPr>
+        <p:txBody>
+          <a:bodyPr/>
+          <a:p/>
+        </p:txBody>
       </p:sp>
       <p:sp>
         <p:nvSpPr>
@@ -2244,6 +2264,10 @@
             <a:prstDash val="solid"/>
           </a:ln>
         </p:spPr>
+        <p:txBody>
+          <a:bodyPr/>
+          <a:p/>
+        </p:txBody>
       </p:sp>
       <p:sp>
         <p:nvSpPr>
@@ -2317,7 +2341,7 @@
                 <a:ea typeface="Arial" pitchFamily="34" charset="-122"/>
                 <a:cs typeface="Arial" pitchFamily="34" charset="-120"/>
               </a:rPr>
-              <a:t>Empresas · Universidades · OTEC · Organismos públicos.</a:t>
+              <a:t>Piloto propuesto: ACHS · IPLACEX · Municipalidad de Santiago · OTEC acreditadas SENCE.</a:t>
             </a:r>
             <a:endParaRPr lang="en-US" sz="1200" dirty="0"/>
           </a:p>
@@ -2349,6 +2373,10 @@
             <a:prstDash val="solid"/>
           </a:ln>
         </p:spPr>
+        <p:txBody>
+          <a:bodyPr/>
+          <a:p/>
+        </p:txBody>
       </p:sp>
       <p:sp>
         <p:nvSpPr>
@@ -2454,6 +2482,10 @@
             <a:prstDash val="solid"/>
           </a:ln>
         </p:spPr>
+        <p:txBody>
+          <a:bodyPr/>
+          <a:p/>
+        </p:txBody>
       </p:sp>
       <p:sp>
         <p:nvSpPr>
@@ -2527,7 +2559,7 @@
                 <a:ea typeface="Arial" pitchFamily="34" charset="-122"/>
                 <a:cs typeface="Arial" pitchFamily="34" charset="-120"/>
               </a:rPr>
-              <a:t>Usuario final, RRHH/capacitación, instituciones, TI y plataformas LMS.</a:t>
+              <a:t>Aprendiz final, RRHH/capacitación (ej. ACHS), IPLACEX, municipios y TI/LMS del cliente.</a:t>
             </a:r>
             <a:endParaRPr lang="en-US" sz="1200" dirty="0"/>
           </a:p>
@@ -2559,6 +2591,10 @@
             <a:prstDash val="solid"/>
           </a:ln>
         </p:spPr>
+        <p:txBody>
+          <a:bodyPr/>
+          <a:p/>
+        </p:txBody>
       </p:sp>
       <p:sp>
         <p:nvSpPr>
@@ -2664,6 +2700,10 @@
             <a:prstDash val="solid"/>
           </a:ln>
         </p:spPr>
+        <p:txBody>
+          <a:bodyPr/>
+          <a:p/>
+        </p:txBody>
       </p:sp>
       <p:sp>
         <p:nvSpPr>
@@ -4111,6 +4151,10 @@
             <a:prstDash val="solid"/>
           </a:ln>
         </p:spPr>
+        <p:txBody>
+          <a:bodyPr/>
+          <a:p/>
+        </p:txBody>
       </p:sp>
       <p:sp>
         <p:nvSpPr>
@@ -4140,6 +4184,10 @@
             <a:prstDash val="solid"/>
           </a:ln>
         </p:spPr>
+        <p:txBody>
+          <a:bodyPr/>
+          <a:p/>
+        </p:txBody>
       </p:sp>
       <p:sp>
         <p:nvSpPr>
@@ -4169,6 +4217,10 @@
             <a:prstDash val="solid"/>
           </a:ln>
         </p:spPr>
+        <p:txBody>
+          <a:bodyPr/>
+          <a:p/>
+        </p:txBody>
       </p:sp>
       <p:sp>
         <p:nvSpPr>
@@ -4203,7 +4255,7 @@
                 <a:ea typeface="Arial" pitchFamily="34" charset="-122"/>
                 <a:cs typeface="Arial" pitchFamily="34" charset="-120"/>
               </a:rPr>
-              <a:t>ANEXO · AUDITORÍA DEL PITCH CON IA</a:t>
+              <a:t>ANEXO · REVISIÓN DEL GUION</a:t>
             </a:r>
             <a:endParaRPr lang="en-US" sz="1100" dirty="0"/>
           </a:p>
@@ -4242,7 +4294,7 @@
                 <a:ea typeface="Arial" pitchFamily="34" charset="-122"/>
                 <a:cs typeface="Arial" pitchFamily="34" charset="-120"/>
               </a:rPr>
-              <a:t>11. Auditoría del guion AIDA</a:t>
+              <a:t>11. Revisión del guion AIDA (calidad oral)</a:t>
             </a:r>
             <a:endParaRPr lang="en-US" sz="2600" dirty="0"/>
           </a:p>
@@ -4274,6 +4326,10 @@
             <a:prstDash val="solid"/>
           </a:ln>
         </p:spPr>
+        <p:txBody>
+          <a:bodyPr/>
+          <a:p/>
+        </p:txBody>
       </p:sp>
       <p:sp>
         <p:nvSpPr>
@@ -4301,6 +4357,10 @@
             <a:prstDash val="solid"/>
           </a:ln>
         </p:spPr>
+        <p:txBody>
+          <a:bodyPr/>
+          <a:p/>
+        </p:txBody>
       </p:sp>
       <p:sp>
         <p:nvSpPr>
@@ -4335,7 +4395,7 @@
                 <a:ea typeface="Arial" pitchFamily="34" charset="-122"/>
                 <a:cs typeface="Arial" pitchFamily="34" charset="-120"/>
               </a:rPr>
-              <a:t>Herramienta</a:t>
+              <a:t>Método</a:t>
             </a:r>
             <a:endParaRPr lang="en-US" sz="1300" dirty="0"/>
           </a:p>
@@ -4374,7 +4434,7 @@
                 <a:ea typeface="Arial" pitchFamily="34" charset="-122"/>
                 <a:cs typeface="Arial" pitchFamily="34" charset="-120"/>
               </a:rPr>
-              <a:t>ChatGPT / Gemini (auditoría de síntesis y tono)</a:t>
+              <a:t>Criterios docentes + lectura en voz alta (cronómetro 1:50–2:15)</a:t>
             </a:r>
             <a:endParaRPr lang="en-US" sz="1200" dirty="0"/>
           </a:p>
@@ -4406,6 +4466,10 @@
             <a:prstDash val="solid"/>
           </a:ln>
         </p:spPr>
+        <p:txBody>
+          <a:bodyPr/>
+          <a:p/>
+        </p:txBody>
       </p:sp>
       <p:sp>
         <p:nvSpPr>
@@ -4433,6 +4497,10 @@
             <a:prstDash val="solid"/>
           </a:ln>
         </p:spPr>
+        <p:txBody>
+          <a:bodyPr/>
+          <a:p/>
+        </p:txBody>
       </p:sp>
       <p:sp>
         <p:nvSpPr>
@@ -4467,7 +4535,7 @@
                 <a:ea typeface="Arial" pitchFamily="34" charset="-122"/>
                 <a:cs typeface="Arial" pitchFamily="34" charset="-120"/>
               </a:rPr>
-              <a:t>Prompt</a:t>
+              <a:t>Checklist</a:t>
             </a:r>
             <a:endParaRPr lang="en-US" sz="1300" dirty="0"/>
           </a:p>
@@ -4506,7 +4574,7 @@
                 <a:ea typeface="Arial" pitchFamily="34" charset="-122"/>
                 <a:cs typeface="Arial" pitchFamily="34" charset="-120"/>
               </a:rPr>
-              <a:t>“Audita este elevator pitch AIDA de ≤2 min para SmartCaps/Laboratorio E-Learning: mejora gancho, empatía con arquetipo, claridad de valor, llamada a la acción y ritmo oral.”</a:t>
+              <a:t>Revisar: gancho, empatía con el aprendiz, valor sin IA/avatars, clientes concretos (ACHS/IPLACEX/Mun. Santiago), CTA de piloto y ritmo oral.</a:t>
             </a:r>
             <a:endParaRPr lang="en-US" sz="1200" dirty="0"/>
           </a:p>
@@ -4538,6 +4606,10 @@
             <a:prstDash val="solid"/>
           </a:ln>
         </p:spPr>
+        <p:txBody>
+          <a:bodyPr/>
+          <a:p/>
+        </p:txBody>
       </p:sp>
       <p:sp>
         <p:nvSpPr>
@@ -4565,6 +4637,10 @@
             <a:prstDash val="solid"/>
           </a:ln>
         </p:spPr>
+        <p:txBody>
+          <a:bodyPr/>
+          <a:p/>
+        </p:txBody>
       </p:sp>
       <p:sp>
         <p:nvSpPr>
@@ -4599,7 +4675,7 @@
                 <a:ea typeface="Arial" pitchFamily="34" charset="-122"/>
                 <a:cs typeface="Arial" pitchFamily="34" charset="-120"/>
               </a:rPr>
-              <a:t>Mejoras IA</a:t>
+              <a:t>Ajustes hechos</a:t>
             </a:r>
             <a:endParaRPr lang="en-US" sz="1300" dirty="0"/>
           </a:p>
@@ -4638,7 +4714,7 @@
                 <a:ea typeface="Arial" pitchFamily="34" charset="-122"/>
                 <a:cs typeface="Arial" pitchFamily="34" charset="-120"/>
               </a:rPr>
-              <a:t>Acortar frases; anclar el dolor en el aprendiz; explicitar LMS/SCORM; cerrar con piloto medible; evitar jerga.</a:t>
+              <a:t>Frases cortas; dolor del aprendiz; LMS/SCORM; clientes con nombre; cierre con piloto medible; sin jerga de IA.</a:t>
             </a:r>
             <a:endParaRPr lang="en-US" sz="1200" dirty="0"/>
           </a:p>
@@ -4670,6 +4746,10 @@
             <a:prstDash val="solid"/>
           </a:ln>
         </p:spPr>
+        <p:txBody>
+          <a:bodyPr/>
+          <a:p/>
+        </p:txBody>
       </p:sp>
       <p:sp>
         <p:nvSpPr>
@@ -4697,6 +4777,10 @@
             <a:prstDash val="solid"/>
           </a:ln>
         </p:spPr>
+        <p:txBody>
+          <a:bodyPr/>
+          <a:p/>
+        </p:txBody>
       </p:sp>
       <p:sp>
         <p:nvSpPr>
@@ -4770,7 +4854,7 @@
                 <a:ea typeface="Arial" pitchFamily="34" charset="-122"/>
                 <a:cs typeface="Arial" pitchFamily="34" charset="-120"/>
               </a:rPr>
-              <a:t>Intro IPLACEX obligatoria; gancho retórico; deseo con trazabilidad institucional; acción = piloto + métricas.</a:t>
+              <a:t>Intro IPLACEX; gancho retórico; deseo con casos reales + trazabilidad; acción = piloto ACHS + métricas; duración 1:50–2:15.</a:t>
             </a:r>
             <a:endParaRPr lang="en-US" sz="1200" dirty="0"/>
           </a:p>
@@ -4802,6 +4886,10 @@
             <a:prstDash val="solid"/>
           </a:ln>
         </p:spPr>
+        <p:txBody>
+          <a:bodyPr/>
+          <a:p/>
+        </p:txBody>
       </p:sp>
       <p:sp>
         <p:nvSpPr>
@@ -4829,6 +4917,10 @@
             <a:prstDash val="solid"/>
           </a:ln>
         </p:spPr>
+        <p:txBody>
+          <a:bodyPr/>
+          <a:p/>
+        </p:txBody>
       </p:sp>
       <p:sp>
         <p:nvSpPr>
@@ -4902,7 +4994,7 @@
                 <a:ea typeface="Arial" pitchFamily="34" charset="-122"/>
                 <a:cs typeface="Arial" pitchFamily="34" charset="-120"/>
               </a:rPr>
-              <a:t>Ver lámina 7 + archivo docs/guion-video-aida-2min.md</a:t>
+              <a:t>Ver lámina 7 + guion-video-aida-2min.md</a:t>
             </a:r>
             <a:endParaRPr lang="en-US" sz="1200" dirty="0"/>
           </a:p>
@@ -4957,6 +5049,10 @@
             <a:prstDash val="solid"/>
           </a:ln>
         </p:spPr>
+        <p:txBody>
+          <a:bodyPr/>
+          <a:p/>
+        </p:txBody>
       </p:sp>
       <p:sp>
         <p:nvSpPr>
@@ -4986,6 +5082,10 @@
             <a:prstDash val="solid"/>
           </a:ln>
         </p:spPr>
+        <p:txBody>
+          <a:bodyPr/>
+          <a:p/>
+        </p:txBody>
       </p:sp>
       <p:sp>
         <p:nvSpPr>
@@ -5015,6 +5115,10 @@
             <a:prstDash val="solid"/>
           </a:ln>
         </p:spPr>
+        <p:txBody>
+          <a:bodyPr/>
+          <a:p/>
+        </p:txBody>
       </p:sp>
       <p:sp>
         <p:nvSpPr>
@@ -5120,6 +5224,10 @@
             <a:prstDash val="solid"/>
           </a:ln>
         </p:spPr>
+        <p:txBody>
+          <a:bodyPr/>
+          <a:p/>
+        </p:txBody>
       </p:sp>
       <p:sp>
         <p:nvSpPr>
@@ -5186,6 +5294,10 @@
             <a:prstDash val="solid"/>
           </a:ln>
         </p:spPr>
+        <p:txBody>
+          <a:bodyPr/>
+          <a:p/>
+        </p:txBody>
       </p:sp>
       <p:sp>
         <p:nvSpPr>
@@ -5220,7 +5332,7 @@
                 <a:ea typeface="Arial" pitchFamily="34" charset="-122"/>
                 <a:cs typeface="Arial" pitchFamily="34" charset="-120"/>
               </a:rPr>
-              <a:t>☐  Video ≤ 2 min — nombre: PaolaCornejo_Video_Examen_IE</a:t>
+              <a:t>☐  Video 1:50–2:15 — nombre: PaolaCornejo_Video_Examen_IE</a:t>
             </a:r>
             <a:endParaRPr lang="en-US" sz="1300" dirty="0"/>
           </a:p>
@@ -5252,6 +5364,10 @@
             <a:prstDash val="solid"/>
           </a:ln>
         </p:spPr>
+        <p:txBody>
+          <a:bodyPr/>
+          <a:p/>
+        </p:txBody>
       </p:sp>
       <p:sp>
         <p:nvSpPr>
@@ -5318,6 +5434,10 @@
             <a:prstDash val="solid"/>
           </a:ln>
         </p:spPr>
+        <p:txBody>
+          <a:bodyPr/>
+          <a:p/>
+        </p:txBody>
       </p:sp>
       <p:sp>
         <p:nvSpPr>
@@ -5352,7 +5472,7 @@
                 <a:ea typeface="Arial" pitchFamily="34" charset="-122"/>
                 <a:cs typeface="Arial" pitchFamily="34" charset="-120"/>
               </a:rPr>
-              <a:t>☐  Estructura AIDA · grabación continua sin cortes · horizontal ≥720p</a:t>
+              <a:t>☐  Estructura AIDA · continuo · ≥720p · SIN IA/avatars · 1:50–2:15</a:t>
             </a:r>
             <a:endParaRPr lang="en-US" sz="1300" dirty="0"/>
           </a:p>
@@ -5384,6 +5504,10 @@
             <a:prstDash val="solid"/>
           </a:ln>
         </p:spPr>
+        <p:txBody>
+          <a:bodyPr/>
+          <a:p/>
+        </p:txBody>
       </p:sp>
       <p:sp>
         <p:nvSpPr>
@@ -5450,6 +5574,10 @@
             <a:prstDash val="solid"/>
           </a:ln>
         </p:spPr>
+        <p:txBody>
+          <a:bodyPr/>
+          <a:p/>
+        </p:txBody>
       </p:sp>
       <p:sp>
         <p:nvSpPr>
@@ -5516,6 +5644,10 @@
             <a:prstDash val="solid"/>
           </a:ln>
         </p:spPr>
+        <p:txBody>
+          <a:bodyPr/>
+          <a:p/>
+        </p:txBody>
       </p:sp>
       <p:sp>
         <p:nvSpPr>
@@ -5582,6 +5714,10 @@
             <a:prstDash val="solid"/>
           </a:ln>
         </p:spPr>
+        <p:txBody>
+          <a:bodyPr/>
+          <a:p/>
+        </p:txBody>
       </p:sp>
       <p:sp>
         <p:nvSpPr>
@@ -8898,7 +9034,7 @@
                 <a:ea typeface="Arial" pitchFamily="34" charset="-122"/>
                 <a:cs typeface="Arial" pitchFamily="34" charset="-120"/>
               </a:rPr>
-              <a:t>Priorizar microcápsulas con videos de casos reales / dramatizaciones y simulaciones ramificadas estáticas. Integración vía LMS/SCORM. Cápsula ≤5 min + tiempo visible antes de empezar. Sin plataforma propia ni avatares de IA.</a:t>
+              <a:t>Priorizar microcápsulas con videos de casos reales / dramatizaciones y simulaciones ramificadas. Integración vía LMS/SCORM. Cápsula ≤5 min + tiempo visible. Sin avatares inteligentes ni plataforma propia.</a:t>
             </a:r>
             <a:endParaRPr lang="en-US" sz="1200" dirty="0"/>
           </a:p>
@@ -9141,30 +9277,6 @@
           </a:p>
         </p:txBody>
       </p:sp>
-      <p:pic>
-        <p:nvPicPr>
-          <p:cNvPr id="7" name="Image 0" descr="/Users/javierpinochetmaureira/Downloads/laboratorio-elearning-prototipo/docs/mockups/lamina-4-16x9.png">    </p:cNvPr>
-          <p:cNvPicPr>
-            <a:picLocks noChangeAspect="1"/>
-          </p:cNvPicPr>
-          <p:nvPr/>
-        </p:nvPicPr>
-        <p:blipFill>
-          <a:blip r:embed="rId1"/>
-          <a:stretch>
-            <a:fillRect/>
-          </a:stretch>
-        </p:blipFill>
-        <p:spPr>
-          <a:xfrm>
-            <a:off x="274320" y="822960"/>
-            <a:ext cx="7589520" cy="4261104"/>
-          </a:xfrm>
-          <a:prstGeom prst="rect">
-            <a:avLst/>
-          </a:prstGeom>
-        </p:spPr>
-      </p:pic>
       <p:sp>
         <p:nvSpPr>
           <p:cNvPr id="8" name="Shape 5"/>
@@ -10122,6 +10234,30 @@
           </a:graphicData>
         </a:graphic>
       </p:graphicFrame>
+      <p:pic>
+        <p:nvPicPr>
+          <p:cNvPr id="17" name="Picture 16" descr="mockup-prototipo-slide4.png"/>
+          <p:cNvPicPr>
+            <a:picLocks noChangeAspect="1"/>
+          </p:cNvPicPr>
+          <p:nvPr/>
+        </p:nvPicPr>
+        <p:blipFill>
+          <a:blip r:embed="rId4"/>
+          <a:stretch>
+            <a:fillRect/>
+          </a:stretch>
+        </p:blipFill>
+        <p:spPr>
+          <a:xfrm>
+            <a:off x="274320" y="822960"/>
+            <a:ext cx="7589520" cy="4261104"/>
+          </a:xfrm>
+          <a:prstGeom prst="rect">
+            <a:avLst/>
+          </a:prstGeom>
+        </p:spPr>
+      </p:pic>
     </p:spTree>
   </p:cSld>
   <p:clrMapOvr>
@@ -10423,7 +10559,7 @@
                 <a:ea typeface="Arial" pitchFamily="34" charset="-122"/>
                 <a:cs typeface="Arial" pitchFamily="34" charset="-120"/>
               </a:rPr>
-              <a:t>Proveedores tech, LMS, especialistas, instituciones educativas</a:t>
+              <a:t>LMS (Moodle/SAP), productoras AV, IPLACEX, mutuales (ej. ACHS) y municipios</a:t>
             </a:r>
             <a:endParaRPr lang="en-US" sz="1100" dirty="0"/>
           </a:p>
@@ -11077,7 +11213,7 @@
                 <a:ea typeface="Arial" pitchFamily="34" charset="-122"/>
                 <a:cs typeface="Arial" pitchFamily="34" charset="-120"/>
               </a:rPr>
-              <a:t>Empresas, universidades, OTEC y organismos públicos</a:t>
+              <a:t>ACHS · IPLACEX · Municipalidad de Santiago · OTEC acreditadas SENCE</a:t>
             </a:r>
             <a:endParaRPr lang="en-US" sz="1100" dirty="0"/>
           </a:p>
@@ -12431,7 +12567,7 @@
                 <a:ea typeface="Arial" pitchFamily="34" charset="-122"/>
                 <a:cs typeface="Arial" pitchFamily="34" charset="-120"/>
               </a:rPr>
-              <a:t>ELEVATOR PITCH · ≤ 2 MIN</a:t>
+              <a:t>ELEVATOR PITCH · 1:50–2:15</a:t>
             </a:r>
             <a:endParaRPr lang="en-US" sz="1100" dirty="0"/>
           </a:p>
@@ -13225,7 +13361,7 @@
                 <a:ea typeface="Arial" pitchFamily="34" charset="-122"/>
                 <a:cs typeface="Arial" pitchFamily="34" charset="-120"/>
               </a:rPr>
-              <a:t>Video OneDrive (IPLACEX): [PEGAR ENLACE AQUÍ]  ·  Archivo: PaolaCornejo_Video_Examen_IE  ·  Intro: Paola Carmen Cornejo Carlevarino</a:t>
+              <a:t>Video OneDrive (IPLACEX): [PEGAR ENLACE] · 1:50–2:15 máx. · Archivo: PaolaCornejo_Video_Examen_IE · Intro: Paola Carmen Cornejo Carlevarino</a:t>
             </a:r>
             <a:endParaRPr lang="en-US" sz="1000" dirty="0"/>
           </a:p>
@@ -13610,7 +13746,7 @@
                           <a:ea typeface="Arial" pitchFamily="34" charset="-122"/>
                           <a:cs typeface="Arial" pitchFamily="34" charset="-120"/>
                         </a:rPr>
-                        <a:t>Sustituir manuales PDF y módulos largos por microcápsulas interactivas con avatar IA.</a:t>
+                        <a:t>Sustituir manuales PDF y módulos largos por microcápsulas interactivas con videos de casos reales / dramatizaciones.</a:t>
                       </a:r>
                       <a:endParaRPr lang="en-US" sz="1300" dirty="0">
                         <a:latin typeface="Arial" charset="0"/>
@@ -13898,7 +14034,7 @@
                           <a:ea typeface="Arial" pitchFamily="34" charset="-122"/>
                           <a:cs typeface="Arial" pitchFamily="34" charset="-120"/>
                         </a:rPr>
-                        <a:t>Pasar de diseño estático a rutas adaptativas según respuestas previas.</a:t>
+                        <a:t>Pasar de diseño estático a rutas de decisión ramificadas según respuestas previas.</a:t>
                       </a:r>
                       <a:endParaRPr lang="en-US" sz="1300" dirty="0">
                         <a:latin typeface="Arial" charset="0"/>

</xml_diff>